<commit_message>
Rebuild hackathon deck with current numbers
- Slides 3 and 4 and their notes updated for the retrained world model
  (PR-AUC 0.30, SHAP deletion 2.1 vs 0.1, 9.5% completeness error)
- Correct the note in docs/hackathon/README.md
</commit_message>
<xml_diff>
--- a/docs/hackathon/SIH_PS26153_deck.pptx
+++ b/docs/hackathon/SIH_PS26153_deck.pptx
@@ -111,27 +111,27 @@
   <p:extLst>
     <p:ext uri="{521415D9-36F7-43E2-AB2F-B90AF26B5E84}">
       <p14:sectionLst xmlns:p14="http://schemas.microsoft.com/office/powerpoint/2010/main">
-        <p14:section name="Problem and approach" id="{aacb0ad1-9c79-1187-f813-37b3c37a777d}">
+        <p14:section name="Problem and approach" id="{793ea386-3e82-a370-c7f4-1af849b708f8}">
           <p14:sldIdLst>
             <p14:sldId id="256"/>
           </p14:sldIdLst>
         </p14:section>
-        <p14:section name="Data and state vector" id="{78f5cbb6-be27-1c02-e3dd-05d7d3dcc069}">
+        <p14:section name="Data and state vector" id="{aa456d7e-721d-63f3-ea6c-b9b654bd168d}">
           <p14:sldIdLst>
             <p14:sldId id="257"/>
           </p14:sldIdLst>
         </p14:section>
-        <p14:section name="World model and explanations" id="{9e2b8728-2372-cc66-ddbb-e2a5a1f1c6d2}">
+        <p14:section name="World model and explanations" id="{96cb97dc-9fa7-2f77-14c3-38bf1df87f22}">
           <p14:sldIdLst>
             <p14:sldId id="258"/>
           </p14:sldIdLst>
         </p14:section>
-        <p14:section name="Results" id="{ff7f35fb-7282-fd01-4032-3b2f0204e3ca}">
+        <p14:section name="Results" id="{d380bf3f-0ae9-1b36-b3ba-f7dbeabd3c7f}">
           <p14:sldIdLst>
             <p14:sldId id="259"/>
           </p14:sldIdLst>
         </p14:section>
-        <p14:section name="Demo, limits, next" id="{6d5dd962-2dad-8930-3c4f-c28bf30faa4d}">
+        <p14:section name="Demo, limits, next" id="{54d7e335-7fb4-f253-d0d3-b8f43dee6132}">
           <p14:sldIdLst>
             <p14:sldId id="260"/>
           </p14:sldIdLst>
@@ -716,7 +716,7 @@
           <a:p>
             <a:r>
               <a:rPr lang="en-US" dirty="0"/>
-              <a:t>The model: one LSTM cell, 128 hidden units, 100,702 parameters. After consuming a state it outputs a Gaussian over the next state (current state plus a learned delta), an infiltration logit and an ATT&amp;CK stage over 7 classes. It reads 6 windows, then rolls out 6 steps feeding its predicted mean state back in, so we get a probability series for the current window and the next six. Explanations use the expected-gradients SHAP estimator, implemented to differentiate through the rollout. Validation: r = 0.99 with the shap library; deleting the top 3, 5 and 10 features lowers the logit by 1.27, 1.74 and 2.73 against about zero for random features; completeness residual 8.8%, so explanations are approximate. Be explicit about the stage mapping caveats: DoS and DDoS fit none of the five stages so they get a sixth class, and no CIC-IDS2017 label is Exfiltration.</a:t>
+              <a:t>The model: one LSTM cell, 128 hidden units, 100,702 parameters. After consuming a state it outputs a Gaussian over the next state (current state plus a learned delta), an infiltration logit and an ATT&amp;CK stage over 7 classes. It reads 6 windows, then rolls out 6 steps feeding its predicted mean state back in, so we get a probability series for the current window and the next six. Explanations use the expected-gradients SHAP estimator, implemented to differentiate through the rollout. Validation: r = 0.99 with the shap library; deleting the top 3, 5 and 10 features lowers the logit by 2.14, 2.81 and 4.11 against about zero for random features (0.09, 0.02 and 0.21); completeness residual 9.5%, so explanations are approximate. One design detail worth mentioning: the infiltration and stage losses are computed on the real history steps only. My first version also trained them on the imagined future steps, which hurt detection (see the results slide). Be explicit about the stage mapping caveats: DoS and DDoS fit none of the five stages so they get a sixth class, and no CIC-IDS2017 label is Exfiltration.</a:t>
             </a:r>
             <a:endParaRPr lang="en-US" dirty="0"/>
           </a:p>
@@ -804,7 +804,7 @@
           <a:p>
             <a:r>
               <a:rPr lang="en-US" dirty="0"/>
-              <a:t>Protocol: blocked 5-fold cross-validation with 60-window blocks and a 12-window purge, scaler refit per fold, thresholds calibrated on a validation fold for a 2% false-alarm target, 3 seeds, block-bootstrap confidence intervals, plus leave-one-attack-type-out. Detecting the current window: logistic regression PR-AUC 0.451, F1 0.43; LSTM classifier 0.350, F1 0.31; world model 0.219, F1 0.20. The paired difference between world model and logistic regression is -0.22 with CI -0.41 to -0.05, so it is significant. The requirement that the temporal model show a measurable improvement is not met on this data. Likely cause, stated as a hypothesis we did not test: a 100k-parameter model overfits about 1,500 overlapping samples, and 41 episodes is too little for dynamics learning. Forecasting 3 minutes ahead: PR-AUC 0.18 to 0.25 for all models, consistent with the earlier finding that attacks start abruptly.</a:t>
+              <a:t>Protocol: blocked 5-fold cross-validation with 60-window blocks and a 12-window purge, scaler refit per fold, thresholds calibrated on a validation fold for a 2% false-alarm target, 3 seeds, block-bootstrap confidence intervals, plus leave-one-attack-type-out. Detecting the current window: logistic regression PR-AUC 0.451, F1 0.43; LSTM classifier 0.350, F1 0.31; world model 0.299, F1 0.30. The paired difference between world model and logistic regression is -0.14 with CI -0.35 to +0.05, so it is not significant, but the world model has the lowest point estimate. The requirement that the temporal model show a measurable improvement is not met on this data. History: my first version scored 0.219 and was significantly worse than logistic regression. I tested overfitting as the cause and it was mostly wrong: shrinking the model to 2,500 parameters, regularising it and down-weighting the dynamics loss changed nothing. The cause was the training objective: the model was also trained to predict attack labels from its own imagined future states, which are close to unpredictable. Training the infiltration head on real steps only lifted it to 0.30. The change was chosen by validation score, but it was made after seeing a poor result, so say so. Forecasting 3 minutes ahead: PR-AUC 0.18 to 0.27 for all models; the world model has the highest point estimate but only 1 of 12 paired comparisons is significant, so do not claim it forecasts. This is consistent with the earlier finding that attacks start abruptly.</a:t>
             </a:r>
             <a:endParaRPr lang="en-US" dirty="0"/>
           </a:p>
@@ -2781,7 +2781,7 @@
                   <a:srgbClr val="2D3A47"/>
                 </a:solidFill>
               </a:rPr>
-              <a:t>Heads read P(infiltration) and the stage at every step.</a:t>
+              <a:t>Heads read P(infiltration) and the stage at every step; those losses use real history steps only.</a:t>
             </a:r>
             <a:endParaRPr lang="en-US" sz="1400" dirty="0"/>
           </a:p>
@@ -2952,7 +2952,7 @@
                   <a:schemeClr val="tx1"/>
                 </a:solidFill>
               </a:rPr>
-              <a:t>1.27 vs 0</a:t>
+              <a:t>2.1 vs 0.1</a:t>
             </a:r>
             <a:endParaRPr lang="en-US" sz="2000" dirty="0"/>
           </a:p>
@@ -3024,7 +3024,7 @@
                   <a:schemeClr val="tx1"/>
                 </a:solidFill>
               </a:rPr>
-              <a:t>8.8%</a:t>
+              <a:t>9.5%</a:t>
             </a:r>
             <a:endParaRPr lang="en-US" sz="2000" dirty="0"/>
           </a:p>
@@ -3226,7 +3226,7 @@
                   <a:srgbClr val="4A5663"/>
                 </a:solidFill>
               </a:rPr>
-              <a:t>Host counterfactual: removing the DDoS pair from the lookback drops P from 0.98 to about 0.05.</a:t>
+              <a:t>Host counterfactual: removing either host of the DDoS pair from the lookback drops P from 1.00 to about 0.07 to 0.11.</a:t>
             </a:r>
             <a:endParaRPr lang="en-US" sz="1200" dirty="0"/>
           </a:p>
@@ -3587,7 +3587,7 @@
         <p:spPr>
           <a:xfrm>
             <a:off x="2778862" y="3767328"/>
-            <a:ext cx="1332064" cy="420624"/>
+            <a:ext cx="1818663" cy="420624"/>
           </a:xfrm>
           <a:prstGeom prst="rect">
             <a:avLst/>
@@ -3606,7 +3606,7 @@
         </p:nvSpPr>
         <p:spPr>
           <a:xfrm>
-            <a:off x="4220653" y="3813048"/>
+            <a:off x="4707252" y="3813048"/>
             <a:ext cx="640080" cy="365760"/>
           </a:xfrm>
           <a:prstGeom prst="rect">
@@ -3628,7 +3628,7 @@
                   <a:schemeClr val="tx1"/>
                 </a:solidFill>
               </a:rPr>
-              <a:t>0.22</a:t>
+              <a:t>0.30</a:t>
             </a:r>
             <a:endParaRPr lang="en-US" sz="1400" dirty="0"/>
           </a:p>
@@ -3664,7 +3664,7 @@
                   <a:srgbClr val="4A5663"/>
                 </a:solidFill>
               </a:rPr>
-              <a:t>95% CI: 0.23 to 0.67, 0.16 to 0.59, 0.11 to 0.37. World model minus logistic regression: -0.22 [-0.41, -0.05]. F1: 0.43, 0.31, 0.20.</a:t>
+              <a:t>95% CI: 0.23 to 0.67, 0.16 to 0.59, 0.14 to 0.53. World model minus logistic regression: -0.14 [-0.35, +0.05], not significant. F1: 0.43, 0.31, 0.30.</a:t>
             </a:r>
             <a:endParaRPr lang="en-US" sz="1200" dirty="0"/>
           </a:p>
@@ -3701,11 +3701,11 @@
                   <a:srgbClr val="2D3A47"/>
                 </a:solidFill>
               </a:rPr>
-              <a:t>Forecasting 3 minutes ahead: </a:t>
+              <a:t>The fix that mattered: </a:t>
             </a:r>
             <a:pPr indent="0" marL="0">
               <a:spcAft>
-                <a:spcPts val="1600"/>
+                <a:spcPts val="1200"/>
               </a:spcAft>
               <a:buNone/>
             </a:pPr>
@@ -3715,7 +3715,7 @@
                   <a:srgbClr val="2D3A47"/>
                 </a:solidFill>
               </a:rPr>
-              <a:t>every model sits at PR-AUC 0.18 to 0.25 against a base rate of 0.11, with no significant differences.</a:t>
+              <a:t>training the infiltration head only on real steps, not imagined future ones, lifted the world model from 0.22 to 0.30.</a:t>
             </a:r>
             <a:endParaRPr lang="en-US" sz="1500" dirty="0"/>
           </a:p>
@@ -3730,11 +3730,11 @@
                   <a:srgbClr val="2D3A47"/>
                 </a:solidFill>
               </a:rPr>
-              <a:t>Unseen attack types: </a:t>
+              <a:t>Forecasting 3 minutes ahead: </a:t>
             </a:r>
             <a:pPr indent="0" marL="0">
               <a:spcAft>
-                <a:spcPts val="1600"/>
+                <a:spcPts val="1200"/>
               </a:spcAft>
               <a:buNone/>
             </a:pPr>
@@ -3744,7 +3744,7 @@
                   <a:srgbClr val="2D3A47"/>
                 </a:solidFill>
               </a:rPr>
-              <a:t>mean recall 0.36 for logistic regression, 0.19 for the world model.</a:t>
+              <a:t>PR-AUC 0.18 to 0.27 against a base rate of 0.11; the world model is highest, but 11 of 12 comparisons are not significant.</a:t>
             </a:r>
             <a:endParaRPr lang="en-US" sz="1500" dirty="0"/>
           </a:p>
@@ -3759,6 +3759,35 @@
                   <a:srgbClr val="2D3A47"/>
                 </a:solidFill>
               </a:rPr>
+              <a:t>Unseen attack types: </a:t>
+            </a:r>
+            <a:pPr indent="0" marL="0">
+              <a:spcAft>
+                <a:spcPts val="1200"/>
+              </a:spcAft>
+              <a:buNone/>
+            </a:pPr>
+            <a:r>
+              <a:rPr lang="en-US" sz="1500" dirty="0">
+                <a:solidFill>
+                  <a:srgbClr val="2D3A47"/>
+                </a:solidFill>
+              </a:rPr>
+              <a:t>mean recall 0.36 for logistic regression, 0.21 for the world model.</a:t>
+            </a:r>
+            <a:endParaRPr lang="en-US" sz="1500" dirty="0"/>
+          </a:p>
+          <a:p>
+            <a:pPr marL="342900" indent="-342900">
+              <a:buSzPct val="100000"/>
+              <a:buChar char="•"/>
+            </a:pPr>
+            <a:r>
+              <a:rPr lang="en-US" sz="1500" b="1" dirty="0">
+                <a:solidFill>
+                  <a:srgbClr val="2D3A47"/>
+                </a:solidFill>
+              </a:rPr>
               <a:t>Dynamics: </a:t>
             </a:r>
             <a:pPr indent="0" marL="0">
@@ -3770,7 +3799,7 @@
                   <a:srgbClr val="2D3A47"/>
                 </a:solidFill>
               </a:rPr>
-              <a:t>the learned next-state model loses to a linear AR(1) predictor.</a:t>
+              <a:t>the learned next-state model ties a linear AR(1) predictor one step ahead and loses further out.</a:t>
             </a:r>
             <a:endParaRPr lang="en-US" sz="1500" dirty="0"/>
           </a:p>

</xml_diff>